<commit_message>
Instructor guide + module6 deck: six release experiments, gravity landscape
M6 section rewritten around the six fan releases (scatter/knife-edge/tadpoles/
DRO/free-return/minimoons) + the restored effective-potential surface; learning
goals extended (ballistic capture, DRO parking, free return, landscape reading);
live-demo script updated (landscape on -> knife-edge -> tadpoles; scatter in MCI;
minimoons as closer). module6.pptx slides 6-7 updated to match. guide.html
regenerated from the markdown.
</commit_message>
<xml_diff>
--- a/slides/module6.pptx
+++ b/slides/module6.pptx
@@ -6472,7 +6472,7 @@
                 </a:solidFill>
                 <a:latin typeface="Arial"/>
               </a:rPr>
-              <a:t>Tiny differences blow up</a:t>
+              <a:t>Knife-edge vs tadpole  —  8 m/s decides everything at L1; 30 m/s changes nothing at L4</a:t>
             </a:r>
             <a:r>
               <a:rPr sz="1300" b="0" i="0">
@@ -6481,7 +6481,7 @@
                 </a:solidFill>
                 <a:latin typeface="Arial"/>
               </a:rPr>
-              <a:t>  —  </a:t>
+              <a:t/>
             </a:r>
             <a:r>
               <a:rPr sz="1250" b="0" i="0">
@@ -6490,7 +6490,7 @@
                 </a:solidFill>
                 <a:latin typeface="Arial"/>
               </a:rPr>
-              <a:t>near-identical releases scatter beyond recognition within days</a:t>
+              <a:t/>
             </a:r>
           </a:p>
         </p:txBody>
@@ -6580,7 +6580,7 @@
                 </a:solidFill>
                 <a:latin typeface="Arial"/>
               </a:rPr>
-              <a:t>Slingshots</a:t>
+              <a:t>Slingshots &amp; captures  —  flybys fling objects past Earth’s Hill sphere — or catch passing minimoons</a:t>
             </a:r>
             <a:r>
               <a:rPr sz="1300" b="0" i="0">
@@ -6589,7 +6589,7 @@
                 </a:solidFill>
                 <a:latin typeface="Arial"/>
               </a:rPr>
-              <a:t>  —  </a:t>
+              <a:t/>
             </a:r>
             <a:r>
               <a:rPr sz="1250" b="0" i="0">
@@ -6598,7 +6598,7 @@
                 </a:solidFill>
                 <a:latin typeface="Arial"/>
               </a:rPr>
-              <a:t>a close lunar pass can fling an object anywhere — even out of the Earth–Moon system</a:t>
+              <a:t/>
             </a:r>
           </a:p>
         </p:txBody>
@@ -7349,7 +7349,7 @@
                 </a:solidFill>
                 <a:latin typeface="Arial"/>
               </a:rPr>
-              <a:t>Read the 1-D force-balance view at L1 and L2 — see whose pull does what.</a:t>
+              <a:t>Read the force balance at L1/L2 — then see it as terrain on the gravity landscape.</a:t>
             </a:r>
           </a:p>
         </p:txBody>
@@ -7509,7 +7509,7 @@
                 </a:solidFill>
                 <a:latin typeface="Arial"/>
               </a:rPr>
-              <a:t>Release a cluster of objects and watch it scatter — rotate for the 3-D view.</a:t>
+              <a:t>Run six releases: L1 knife-edge, L4 tadpoles, lunar slingshots, DRO parking, free returns, minimoons.</a:t>
             </a:r>
           </a:p>
         </p:txBody>

</xml_diff>